<commit_message>
feat: add Stage 0 authorization and projection boundaries
</commit_message>
<xml_diff>
--- a/docs/presentations/synapsegit_user_scenarios_ja.pptx
+++ b/docs/presentations/synapsegit_user_scenarios_ja.pptx
@@ -5062,7 +5062,7 @@
       <p:grpSpPr/>
       <p:sp>
         <p:nvSpPr>
-          <p:cNvPr id="2" name="Slide title: 現在地・信頼できる見方・次の実装"/>
+          <p:cNvPr id="2" name="Slide title: 現在地・信頼できる境界・次の実装"/>
           <p:cNvSpPr>
             <a:spLocks noGrp="1"/>
           </p:cNvSpPr>
@@ -5089,7 +5089,7 @@
                 <a:latin typeface="Noto Sans JP"/>
                 <a:ea typeface="Noto Sans JP"/>
               </a:rPr>
-              <a:t>現在地・信頼できる見方・次の実装</a:t>
+              <a:t>現在地・信頼できる境界・次の実装</a:t>
             </a:r>
           </a:p>
         </p:txBody>
@@ -5176,7 +5176,7 @@
       </p:sp>
       <p:sp>
         <p:nvSpPr>
-          <p:cNvPr id="5" name="Card: NOW · 実装済み">
+          <p:cNvPr id="5" name="Card: 実装済み · Core">
             <a:extLst>
               <a:ext uri="{C183D7F6-B498-43B3-948B-1728B52AA6E4}">
                 <adec:decorative xmlns:adec="http://schemas.microsoft.com/office/drawing/2017/decorative" val="1"/>
@@ -5227,7 +5227,7 @@
       </p:sp>
       <p:sp>
         <p:nvSpPr>
-          <p:cNvPr id="6" name="Accent: NOW · 実装済み">
+          <p:cNvPr id="6" name="Accent: 実装済み · Core">
             <a:extLst>
               <a:ext uri="{C183D7F6-B498-43B3-948B-1728B52AA6E4}">
                 <adec:decorative xmlns:adec="http://schemas.microsoft.com/office/drawing/2017/decorative" val="1"/>
@@ -5276,7 +5276,7 @@
       </p:sp>
       <p:sp>
         <p:nvSpPr>
-          <p:cNvPr id="7" name="Text: NOW · 実装済み"/>
+          <p:cNvPr id="7" name="Text: 実装済み · Core"/>
           <p:cNvSpPr txBox="1"/>
           <p:nvPr/>
         </p:nvSpPr>
@@ -5309,14 +5309,14 @@
                 <a:latin typeface="Noto Sans JP"/>
                 <a:ea typeface="Noto Sans JP"/>
               </a:rPr>
-              <a:t>NOW · 実装済み</a:t>
-            </a:r>
-          </a:p>
-        </p:txBody>
-      </p:sp>
-      <p:sp>
-        <p:nvSpPr>
-          <p:cNvPr id="8" name="Text: Rust strict JSON&#10;canonic"/>
+              <a:t>実装済み · Core</a:t>
+            </a:r>
+          </a:p>
+        </p:txBody>
+      </p:sp>
+      <p:sp>
+        <p:nvSpPr>
+          <p:cNvPr id="8" name="Text: strict JSON／schema&#10;canon"/>
           <p:cNvSpPr txBox="1"/>
           <p:nvPr/>
         </p:nvSpPr>
@@ -5349,7 +5349,7 @@
                 <a:latin typeface="Noto Sans JP"/>
                 <a:ea typeface="Noto Sans JP"/>
               </a:rPr>
-              <a:t>Rust strict JSON</a:t>
+              <a:t>strict JSON／schema</a:t>
             </a:r>
             <a:br/>
             <a:r>
@@ -5360,7 +5360,7 @@
                 <a:latin typeface="Noto Sans JP"/>
                 <a:ea typeface="Noto Sans JP"/>
               </a:rPr>
-              <a:t>canonical/OID</a:t>
+              <a:t>canonical OID</a:t>
             </a:r>
             <a:br/>
             <a:r>
@@ -5371,63 +5371,14 @@
                 <a:latin typeface="Noto Sans JP"/>
                 <a:ea typeface="Noto Sans JP"/>
               </a:rPr>
-              <a:t>17 golden＋Blob一致</a:t>
-            </a:r>
-          </a:p>
-        </p:txBody>
-      </p:sp>
-      <p:sp>
-        <p:nvSpPr>
-          <p:cNvPr id="9" name="Chevron 8">
-            <a:extLst>
-              <a:ext uri="{C183D7F6-B498-43B3-948B-1728B52AA6E4}">
-                <adec:decorative xmlns:adec="http://schemas.microsoft.com/office/drawing/2017/decorative" val="1"/>
-              </a:ext>
-            </a:extLst>
-          </p:cNvPr>
-          <p:cNvSpPr/>
-          <p:nvPr/>
-        </p:nvSpPr>
-        <p:spPr>
-          <a:xfrm>
-            <a:off x="4151376" y="1874519"/>
-            <a:ext cx="219456" cy="384048"/>
-          </a:xfrm>
-          <a:prstGeom prst="chevron">
-            <a:avLst/>
-          </a:prstGeom>
-          <a:solidFill>
-            <a:srgbClr val="7B858A"/>
-          </a:solidFill>
-          <a:ln>
-            <a:noFill/>
-          </a:ln>
-        </p:spPr>
-        <p:style>
-          <a:lnRef idx="1">
-            <a:schemeClr val="accent1"/>
-          </a:lnRef>
-          <a:fillRef idx="3">
-            <a:schemeClr val="accent1"/>
-          </a:fillRef>
-          <a:effectRef idx="2">
-            <a:schemeClr val="accent1"/>
-          </a:effectRef>
-          <a:fontRef idx="minor">
-            <a:schemeClr val="lt1"/>
-          </a:fontRef>
-        </p:style>
-        <p:txBody>
-          <a:bodyPr rtlCol="0" anchor="ctr"/>
-          <a:lstStyle/>
-          <a:p>
-            <a:pPr algn="ctr"/>
-          </a:p>
-        </p:txBody>
-      </p:sp>
-      <p:sp>
-        <p:nvSpPr>
-          <p:cNvPr id="10" name="Card: NEXT · Workstream A">
+              <a:t>validated ingest</a:t>
+            </a:r>
+          </a:p>
+        </p:txBody>
+      </p:sp>
+      <p:sp>
+        <p:nvSpPr>
+          <p:cNvPr id="9" name="Card: 実装済み · Local">
             <a:extLst>
               <a:ext uri="{C183D7F6-B498-43B3-948B-1728B52AA6E4}">
                 <adec:decorative xmlns:adec="http://schemas.microsoft.com/office/drawing/2017/decorative" val="1"/>
@@ -5478,7 +5429,7 @@
       </p:sp>
       <p:sp>
         <p:nvSpPr>
-          <p:cNvPr id="11" name="Accent: NEXT · Workstream A">
+          <p:cNvPr id="10" name="Accent: 実装済み · Local">
             <a:extLst>
               <a:ext uri="{C183D7F6-B498-43B3-948B-1728B52AA6E4}">
                 <adec:decorative xmlns:adec="http://schemas.microsoft.com/office/drawing/2017/decorative" val="1"/>
@@ -5497,7 +5448,7 @@
             <a:avLst/>
           </a:prstGeom>
           <a:solidFill>
-            <a:srgbClr val="4E51A8"/>
+            <a:srgbClr val="0B6E69"/>
           </a:solidFill>
           <a:ln>
             <a:noFill/>
@@ -5527,7 +5478,7 @@
       </p:sp>
       <p:sp>
         <p:nvSpPr>
-          <p:cNvPr id="12" name="Text: NEXT · Workstream A"/>
+          <p:cNvPr id="11" name="Text: 実装済み · Local"/>
           <p:cNvSpPr txBox="1"/>
           <p:nvPr/>
         </p:nvSpPr>
@@ -5555,19 +5506,19 @@
             <a:r>
               <a:rPr sz="1550" b="1" lang="ja-JP">
                 <a:solidFill>
-                  <a:srgbClr val="4E51A8"/>
-                </a:solidFill>
-                <a:latin typeface="Noto Sans JP"/>
-                <a:ea typeface="Noto Sans JP"/>
-              </a:rPr>
-              <a:t>NEXT · Workstream A</a:t>
-            </a:r>
-          </a:p>
-        </p:txBody>
-      </p:sp>
-      <p:sp>
-        <p:nvSpPr>
-          <p:cNvPr id="13" name="Text: schema dispatch&#10;semantic"/>
+                  <a:srgbClr val="0B6E69"/>
+                </a:solidFill>
+                <a:latin typeface="Noto Sans JP"/>
+                <a:ea typeface="Noto Sans JP"/>
+              </a:rPr>
+              <a:t>実装済み · Local</a:t>
+            </a:r>
+          </a:p>
+        </p:txBody>
+      </p:sp>
+      <p:sp>
+        <p:nvSpPr>
+          <p:cNvPr id="12" name="Text: filesystem／Ref CAS&#10;archi"/>
           <p:cNvSpPr txBox="1"/>
           <p:nvPr/>
         </p:nvSpPr>
@@ -5600,7 +5551,7 @@
                 <a:latin typeface="Noto Sans JP"/>
                 <a:ea typeface="Noto Sans JP"/>
               </a:rPr>
-              <a:t>schema dispatch</a:t>
+              <a:t>filesystem／Ref CAS</a:t>
             </a:r>
             <a:br/>
             <a:r>
@@ -5611,7 +5562,7 @@
                 <a:latin typeface="Noto Sans JP"/>
                 <a:ea typeface="Noto Sans JP"/>
               </a:rPr>
-              <a:t>semantic validation</a:t>
+              <a:t>archive round trip</a:t>
             </a:r>
             <a:br/>
             <a:r>
@@ -5622,63 +5573,14 @@
                 <a:latin typeface="Noto Sans JP"/>
                 <a:ea typeface="Noto Sans JP"/>
               </a:rPr>
-              <a:t>validated OID入口</a:t>
-            </a:r>
-          </a:p>
-        </p:txBody>
-      </p:sp>
-      <p:sp>
-        <p:nvSpPr>
-          <p:cNvPr id="14" name="Chevron 13">
-            <a:extLst>
-              <a:ext uri="{C183D7F6-B498-43B3-948B-1728B52AA6E4}">
-                <adec:decorative xmlns:adec="http://schemas.microsoft.com/office/drawing/2017/decorative" val="1"/>
-              </a:ext>
-            </a:extLst>
-          </p:cNvPr>
-          <p:cNvSpPr/>
-          <p:nvPr/>
-        </p:nvSpPr>
-        <p:spPr>
-          <a:xfrm>
-            <a:off x="7900415" y="1874519"/>
-            <a:ext cx="219456" cy="384048"/>
-          </a:xfrm>
-          <a:prstGeom prst="chevron">
-            <a:avLst/>
-          </a:prstGeom>
-          <a:solidFill>
-            <a:srgbClr val="7B858A"/>
-          </a:solidFill>
-          <a:ln>
-            <a:noFill/>
-          </a:ln>
-        </p:spPr>
-        <p:style>
-          <a:lnRef idx="1">
-            <a:schemeClr val="accent1"/>
-          </a:lnRef>
-          <a:fillRef idx="3">
-            <a:schemeClr val="accent1"/>
-          </a:fillRef>
-          <a:effectRef idx="2">
-            <a:schemeClr val="accent1"/>
-          </a:effectRef>
-          <a:fontRef idx="minor">
-            <a:schemeClr val="lt1"/>
-          </a:fontRef>
-        </p:style>
-        <p:txBody>
-          <a:bodyPr rtlCol="0" anchor="ctr"/>
-          <a:lstStyle/>
-          <a:p>
-            <a:pPr algn="ctr"/>
-          </a:p>
-        </p:txBody>
-      </p:sp>
-      <p:sp>
-        <p:nvSpPr>
-          <p:cNvPr id="15" name="Card: THEN · Vertical slice">
+              <a:t>SQLite projection／lineage</a:t>
+            </a:r>
+          </a:p>
+        </p:txBody>
+      </p:sp>
+      <p:sp>
+        <p:nvSpPr>
+          <p:cNvPr id="13" name="Card: 実装済み · App routes">
             <a:extLst>
               <a:ext uri="{C183D7F6-B498-43B3-948B-1728B52AA6E4}">
                 <adec:decorative xmlns:adec="http://schemas.microsoft.com/office/drawing/2017/decorative" val="1"/>
@@ -5729,7 +5631,7 @@
       </p:sp>
       <p:sp>
         <p:nvSpPr>
-          <p:cNvPr id="16" name="Accent: THEN · Vertical slice">
+          <p:cNvPr id="14" name="Accent: 実装済み · App routes">
             <a:extLst>
               <a:ext uri="{C183D7F6-B498-43B3-948B-1728B52AA6E4}">
                 <adec:decorative xmlns:adec="http://schemas.microsoft.com/office/drawing/2017/decorative" val="1"/>
@@ -5748,7 +5650,7 @@
             <a:avLst/>
           </a:prstGeom>
           <a:solidFill>
-            <a:srgbClr val="8C450E"/>
+            <a:srgbClr val="74428A"/>
           </a:solidFill>
           <a:ln>
             <a:noFill/>
@@ -5778,7 +5680,7 @@
       </p:sp>
       <p:sp>
         <p:nvSpPr>
-          <p:cNvPr id="17" name="Text: THEN · Vertical slice"/>
+          <p:cNvPr id="15" name="Text: 実装済み · App routes"/>
           <p:cNvSpPr txBox="1"/>
           <p:nvPr/>
         </p:nvSpPr>
@@ -5806,19 +5708,19 @@
             <a:r>
               <a:rPr sz="1550" b="1" lang="ja-JP">
                 <a:solidFill>
-                  <a:srgbClr val="8C450E"/>
-                </a:solidFill>
-                <a:latin typeface="Noto Sans JP"/>
-                <a:ea typeface="Noto Sans JP"/>
-              </a:rPr>
-              <a:t>THEN · Vertical slice</a:t>
-            </a:r>
-          </a:p>
-        </p:txBody>
-      </p:sp>
-      <p:sp>
-        <p:nvSpPr>
-          <p:cNvPr id="18" name="Text: filesystem CAS&#10;SQLite Re"/>
+                  <a:srgbClr val="74428A"/>
+                </a:solidFill>
+                <a:latin typeface="Noto Sans JP"/>
+                <a:ea typeface="Noto Sans JP"/>
+              </a:rPr>
+              <a:t>実装済み · App routes</a:t>
+            </a:r>
+          </a:p>
+        </p:txBody>
+      </p:sp>
+      <p:sp>
+        <p:nvSpPr>
+          <p:cNvPr id="16" name="Text: AI: preflight／Executor&#10;H"/>
           <p:cNvSpPr txBox="1"/>
           <p:nvPr/>
         </p:nvSpPr>
@@ -5851,7 +5753,7 @@
                 <a:latin typeface="Noto Sans JP"/>
                 <a:ea typeface="Noto Sans JP"/>
               </a:rPr>
-              <a:t>filesystem CAS</a:t>
+              <a:t>AI: preflight／Executor</a:t>
             </a:r>
             <a:br/>
             <a:r>
@@ -5862,7 +5764,7 @@
                 <a:latin typeface="Noto Sans JP"/>
                 <a:ea typeface="Noto Sans JP"/>
               </a:rPr>
-              <a:t>SQLite Ref CAS</a:t>
+              <a:t>Human: admitted handle／permit</a:t>
             </a:r>
             <a:br/>
             <a:r>
@@ -5873,14 +5775,14 @@
                 <a:latin typeface="Noto Sans JP"/>
                 <a:ea typeface="Noto Sans JP"/>
               </a:rPr>
-              <a:t>Observation pilot</a:t>
-            </a:r>
-          </a:p>
-        </p:txBody>
-      </p:sp>
-      <p:sp>
-        <p:nvSpPr>
-          <p:cNvPr id="19" name="Card: 設計原則（未実装を含む）">
+              <a:t>ACL/profile FIFO fence</a:t>
+            </a:r>
+          </a:p>
+        </p:txBody>
+      </p:sp>
+      <p:sp>
+        <p:nvSpPr>
+          <p:cNvPr id="17" name="Card: 信頼できる見方">
             <a:extLst>
               <a:ext uri="{C183D7F6-B498-43B3-948B-1728B52AA6E4}">
                 <adec:decorative xmlns:adec="http://schemas.microsoft.com/office/drawing/2017/decorative" val="1"/>
@@ -5931,7 +5833,7 @@
       </p:sp>
       <p:sp>
         <p:nvSpPr>
-          <p:cNvPr id="20" name="Accent: 設計原則（未実装を含む）">
+          <p:cNvPr id="18" name="Accent: 信頼できる見方">
             <a:extLst>
               <a:ext uri="{C183D7F6-B498-43B3-948B-1728B52AA6E4}">
                 <adec:decorative xmlns:adec="http://schemas.microsoft.com/office/drawing/2017/decorative" val="1"/>
@@ -5980,7 +5882,7 @@
       </p:sp>
       <p:sp>
         <p:nvSpPr>
-          <p:cNvPr id="21" name="Text: 設計原則（未実装を含む）"/>
+          <p:cNvPr id="19" name="Text: 信頼できる見方"/>
           <p:cNvSpPr txBox="1"/>
           <p:nvPr/>
         </p:nvSpPr>
@@ -6013,14 +5915,14 @@
                 <a:latin typeface="Noto Sans JP"/>
                 <a:ea typeface="Noto Sans JP"/>
               </a:rPr>
-              <a:t>設計原則（未実装を含む）</a:t>
-            </a:r>
-          </a:p>
-        </p:txBody>
-      </p:sp>
-      <p:sp>
-        <p:nvSpPr>
-          <p:cNvPr id="22" name="Text: 記録をhashで照合&#10;観測条件・欠測・revie"/>
+              <a:t>信頼できる見方</a:t>
+            </a:r>
+          </a:p>
+        </p:txBody>
+      </p:sp>
+      <p:sp>
+        <p:nvSpPr>
+          <p:cNvPr id="20" name="Text: hashはbyte identityを照合&#10;AI"/>
           <p:cNvSpPr txBox="1"/>
           <p:nvPr/>
         </p:nvSpPr>
@@ -6053,7 +5955,7 @@
                 <a:latin typeface="Noto Sans JP"/>
                 <a:ea typeface="Noto Sans JP"/>
               </a:rPr>
-              <a:t>記録をhashで照合</a:t>
+              <a:t>hashはbyte identityを照合</a:t>
             </a:r>
             <a:br/>
             <a:r>
@@ -6064,7 +5966,7 @@
                 <a:latin typeface="Noto Sans JP"/>
                 <a:ea typeface="Noto Sans JP"/>
               </a:rPr>
-              <a:t>観測条件・欠測・review範囲を表示</a:t>
+              <a:t>AI／Human appはprocess-local</a:t>
             </a:r>
             <a:br/>
             <a:r>
@@ -6075,7 +5977,7 @@
                 <a:latin typeface="Noto Sans JP"/>
                 <a:ea typeface="Noto Sans JP"/>
               </a:rPr>
-              <a:t>原本と公開previewを分離</a:t>
+              <a:t>Human認証はpublish冒頭1回</a:t>
             </a:r>
             <a:br/>
             <a:r>
@@ -6086,14 +5988,14 @@
                 <a:latin typeface="Noto Sans JP"/>
                 <a:ea typeface="Noto Sans JP"/>
               </a:rPr>
-              <a:t>人の判断からEvidenceへ到達</a:t>
-            </a:r>
-          </a:p>
-        </p:txBody>
-      </p:sp>
-      <p:sp>
-        <p:nvSpPr>
-          <p:cNvPr id="23" name="Card: 現在は未実装">
+              <a:t>TTLが外部revocation差を限定</a:t>
+            </a:r>
+          </a:p>
+        </p:txBody>
+      </p:sp>
+      <p:sp>
+        <p:nvSpPr>
+          <p:cNvPr id="21" name="Card: 未実装・次">
             <a:extLst>
               <a:ext uri="{C183D7F6-B498-43B3-948B-1728B52AA6E4}">
                 <adec:decorative xmlns:adec="http://schemas.microsoft.com/office/drawing/2017/decorative" val="1"/>
@@ -6144,7 +6046,7 @@
       </p:sp>
       <p:sp>
         <p:nvSpPr>
-          <p:cNvPr id="24" name="Accent: 現在は未実装">
+          <p:cNvPr id="22" name="Accent: 未実装・次">
             <a:extLst>
               <a:ext uri="{C183D7F6-B498-43B3-948B-1728B52AA6E4}">
                 <adec:decorative xmlns:adec="http://schemas.microsoft.com/office/drawing/2017/decorative" val="1"/>
@@ -6193,7 +6095,7 @@
       </p:sp>
       <p:sp>
         <p:nvSpPr>
-          <p:cNvPr id="25" name="Text: 現在は未実装"/>
+          <p:cNvPr id="23" name="Text: 未実装・次"/>
           <p:cNvSpPr txBox="1"/>
           <p:nvPr/>
         </p:nvSpPr>
@@ -6226,14 +6128,14 @@
                 <a:latin typeface="Noto Sans JP"/>
                 <a:ea typeface="Noto Sans JP"/>
               </a:rPr>
-              <a:t>現在は未実装</a:t>
-            </a:r>
-          </a:p>
-        </p:txBody>
-      </p:sp>
-      <p:sp>
-        <p:nvSpPr>
-          <p:cNvPr id="26" name="Text: capture／compare／report U"/>
+              <a:t>未実装・次</a:t>
+            </a:r>
+          </a:p>
+        </p:txBody>
+      </p:sp>
+      <p:sp>
+        <p:nvSpPr>
+          <p:cNvPr id="24" name="Text: HTTP／JWT／durable ACL・per"/>
           <p:cNvSpPr txBox="1"/>
           <p:nvPr/>
         </p:nvSpPr>
@@ -6266,7 +6168,7 @@
                 <a:latin typeface="Noto Sans JP"/>
                 <a:ea typeface="Noto Sans JP"/>
               </a:rPr>
-              <a:t>capture／compare／report UI</a:t>
+              <a:t>HTTP／JWT／durable ACL・permit</a:t>
             </a:r>
             <a:br/>
             <a:r>
@@ -6277,7 +6179,7 @@
                 <a:latin typeface="Noto Sans JP"/>
                 <a:ea typeface="Noto Sans JP"/>
               </a:rPr>
-              <a:t>filesystem CAS／Refs／reflog</a:t>
+              <a:t>OS sandbox／release／quorum</a:t>
             </a:r>
             <a:br/>
             <a:r>
@@ -6288,7 +6190,7 @@
                 <a:latin typeface="Noto Sans JP"/>
                 <a:ea typeface="Noto Sans JP"/>
               </a:rPr>
-              <a:t>archive実ファイルround trip</a:t>
+              <a:t>Projection app route</a:t>
             </a:r>
             <a:br/>
             <a:r>
@@ -6299,14 +6201,14 @@
                 <a:latin typeface="Noto Sans JP"/>
                 <a:ea typeface="Noto Sans JP"/>
               </a:rPr>
-              <a:t>AI Proposal／Human Gate authorization</a:t>
-            </a:r>
-          </a:p>
-        </p:txBody>
-      </p:sp>
-      <p:sp>
-        <p:nvSpPr>
-          <p:cNvPr id="27" name="Text: しない約束：作者性・現実・契約適合の自動証明／常"/>
+              <a:t>Observation／Surreal／creator UI</a:t>
+            </a:r>
+          </a:p>
+        </p:txBody>
+      </p:sp>
+      <p:sp>
+        <p:nvSpPr>
+          <p:cNvPr id="25" name="Text: しない約束：作者性・現実・契約適合の自動証明／常"/>
           <p:cNvSpPr txBox="1"/>
           <p:nvPr/>
         </p:nvSpPr>
@@ -6346,7 +6248,7 @@
       </p:sp>
       <p:sp>
         <p:nvSpPr>
-          <p:cNvPr id="28" name="Text: branch: main resources"/>
+          <p:cNvPr id="26" name="Text: branch: main resources"/>
           <p:cNvSpPr txBox="1"/>
           <p:nvPr/>
         </p:nvSpPr>
@@ -6386,7 +6288,7 @@
       </p:sp>
       <p:sp>
         <p:nvSpPr>
-          <p:cNvPr id="29" name="Usage guide" title="Usage guide" descr="branch main link: https://github.com/howlrs/synapsegit/blob/main/docs/usage_guide.md">
+          <p:cNvPr id="27" name="Usage guide" title="Usage guide" descr="branch main link: https://github.com/howlrs/synapsegit/blob/main/docs/usage_guide.md">
             <a:hlinkClick r:id="rId2"/>
           </p:cNvPr>
           <p:cNvSpPr/>
@@ -6444,7 +6346,7 @@
       </p:sp>
       <p:sp>
         <p:nvSpPr>
-          <p:cNvPr id="30" name="Core concept" title="Core concept" descr="branch main link: https://github.com/howlrs/synapsegit/blob/main/docs/core_concept.md">
+          <p:cNvPr id="28" name="Core concept" title="Core concept" descr="branch main link: https://github.com/howlrs/synapsegit/blob/main/docs/core_concept.md">
             <a:hlinkClick r:id="rId3"/>
           </p:cNvPr>
           <p:cNvSpPr/>
@@ -6502,7 +6404,7 @@
       </p:sp>
       <p:sp>
         <p:nvSpPr>
-          <p:cNvPr id="31" name="Stage 0 plan" title="Stage 0 plan" descr="branch main link: https://github.com/howlrs/synapsegit/blob/main/docs/stage0_execution_plan.md">
+          <p:cNvPr id="29" name="Stage 0 plan" title="Stage 0 plan" descr="branch main link: https://github.com/howlrs/synapsegit/blob/main/docs/stage0_execution_plan.md">
             <a:hlinkClick r:id="rId4"/>
           </p:cNvPr>
           <p:cNvSpPr/>
@@ -6560,7 +6462,7 @@
       </p:sp>
       <p:sp>
         <p:nvSpPr>
-          <p:cNvPr id="32" name="Protocol v0.1" title="Protocol v0.1" descr="branch main link: https://github.com/howlrs/synapsegit/blob/main/spec/core/v0.1/README.md">
+          <p:cNvPr id="30" name="Protocol v0.1" title="Protocol v0.1" descr="branch main link: https://github.com/howlrs/synapsegit/blob/main/spec/core/v0.1/README.md">
             <a:hlinkClick r:id="rId5"/>
           </p:cNvPr>
           <p:cNvSpPr/>
@@ -6618,7 +6520,7 @@
       </p:sp>
       <p:sp>
         <p:nvSpPr>
-          <p:cNvPr id="33" name="Text: リンク先はGitHub mainブランチ。mai"/>
+          <p:cNvPr id="31" name="Text: リンク先はGitHub mainブランチ。mai"/>
           <p:cNvSpPr txBox="1"/>
           <p:nvPr/>
         </p:nvSpPr>
@@ -6658,7 +6560,7 @@
       </p:sp>
       <p:cxnSp>
         <p:nvCxnSpPr>
-          <p:cNvPr id="34" name="Connector 33">
+          <p:cNvPr id="32" name="Connector 31">
             <a:extLst>
               <a:ext uri="{C183D7F6-B498-43B3-948B-1728B52AA6E4}">
                 <adec:decorative xmlns:adec="http://schemas.microsoft.com/office/drawing/2017/decorative" val="1"/>
@@ -6699,7 +6601,7 @@
       </p:cxnSp>
       <p:sp>
         <p:nvSpPr>
-          <p:cNvPr id="35" name="Text: Concept visual · branch:"/>
+          <p:cNvPr id="33" name="Text: Concept visual · branch:"/>
           <p:cNvSpPr txBox="1"/>
           <p:nvPr/>
         </p:nvSpPr>
@@ -6740,7 +6642,7 @@
       </p:sp>
       <p:sp>
         <p:nvSpPr>
-          <p:cNvPr id="36" name="Text: README · Core concept §2"/>
+          <p:cNvPr id="34" name="Text: README · Security model "/>
           <p:cNvSpPr txBox="1"/>
           <p:nvPr/>
         </p:nvSpPr>
@@ -6773,14 +6675,14 @@
                 <a:latin typeface="Noto Sans JP"/>
                 <a:ea typeface="Noto Sans JP"/>
               </a:rPr>
-              <a:t>README · Core concept §20.7 · Stage 0 exit gate</a:t>
-            </a:r>
-          </a:p>
-        </p:txBody>
-      </p:sp>
-      <p:sp>
-        <p:nvSpPr>
-          <p:cNvPr id="37" name="Text: 10"/>
+              <a:t>README · Security model · Stage 0 execution plan</a:t>
+            </a:r>
+          </a:p>
+        </p:txBody>
+      </p:sp>
+      <p:sp>
+        <p:nvSpPr>
+          <p:cNvPr id="35" name="Text: 10"/>
           <p:cNvSpPr txBox="1"/>
           <p:nvPr/>
         </p:nvSpPr>

</xml_diff>